<commit_message>
update a few typos
</commit_message>
<xml_diff>
--- a/topic12-monads/unit-12a-lectures/talk-1/a-monads.pptx
+++ b/topic12-monads/unit-12a-lectures/talk-1/a-monads.pptx
@@ -9569,7 +9569,14 @@
                 <a:latin typeface="Tahoma" panose="020B0604030504040204" pitchFamily="34" charset="0"/>
                 <a:ea typeface="MS PGothic" panose="020B0600070205080204" pitchFamily="34" charset="-128"/>
               </a:rPr>
-              <a:t>Topic 12.1 – Monads</a:t>
+              <a:t>Topic 12 </a:t>
+            </a:r>
+            <a:r>
+              <a:rPr kumimoji="1" lang="en-US" altLang="en-US" sz="2400" dirty="0">
+                <a:latin typeface="Tahoma" panose="020B0604030504040204" pitchFamily="34" charset="0"/>
+                <a:ea typeface="MS PGothic" panose="020B0600070205080204" pitchFamily="34" charset="-128"/>
+              </a:rPr>
+              <a:t>– Monads</a:t>
             </a:r>
           </a:p>
         </p:txBody>
@@ -18313,41 +18320,6 @@
           </a:p>
         </p:txBody>
       </p:sp>
-      <p:sp>
-        <p:nvSpPr>
-          <p:cNvPr id="6" name="TextBox 5">
-            <a:extLst>
-              <a:ext uri="{FF2B5EF4-FFF2-40B4-BE49-F238E27FC236}">
-                <a16:creationId xmlns:a16="http://schemas.microsoft.com/office/drawing/2014/main" id="{8A52058E-4C39-88DA-272D-0CA3A15E537E}"/>
-              </a:ext>
-            </a:extLst>
-          </p:cNvPr>
-          <p:cNvSpPr txBox="1"/>
-          <p:nvPr/>
-        </p:nvSpPr>
-        <p:spPr>
-          <a:xfrm>
-            <a:off x="325464" y="5315919"/>
-            <a:ext cx="728421" cy="369332"/>
-          </a:xfrm>
-          <a:prstGeom prst="rect">
-            <a:avLst/>
-          </a:prstGeom>
-          <a:noFill/>
-        </p:spPr>
-        <p:txBody>
-          <a:bodyPr wrap="square" rtlCol="0">
-            <a:spAutoFit/>
-          </a:bodyPr>
-          <a:lstStyle/>
-          <a:p>
-            <a:r>
-              <a:rPr lang="en-US" dirty="0"/>
-              <a:t>or</a:t>
-            </a:r>
-          </a:p>
-        </p:txBody>
-      </p:sp>
     </p:spTree>
     <p:extLst>
       <p:ext uri="{BB962C8B-B14F-4D97-AF65-F5344CB8AC3E}">
@@ -18370,6 +18342,9 @@
                     <p:cTn id="3" fill="hold">
                       <p:stCondLst>
                         <p:cond delay="indefinite"/>
+                        <p:cond evt="onBegin" delay="0">
+                          <p:tn val="2"/>
+                        </p:cond>
                       </p:stCondLst>
                       <p:childTnLst>
                         <p:par>
@@ -18379,7 +18354,7 @@
                             </p:stCondLst>
                             <p:childTnLst>
                               <p:par>
-                                <p:cTn id="5" presetID="2" presetClass="entr" presetSubtype="4" fill="hold" grpId="0" nodeType="clickEffect">
+                                <p:cTn id="5" presetID="2" presetClass="entr" presetSubtype="4" fill="hold" grpId="0" nodeType="withEffect">
                                   <p:stCondLst>
                                     <p:cond delay="0"/>
                                   </p:stCondLst>
@@ -18392,7 +18367,7 @@
                                           </p:stCondLst>
                                         </p:cTn>
                                         <p:tgtEl>
-                                          <p:spTgt spid="6"/>
+                                          <p:spTgt spid="3"/>
                                         </p:tgtEl>
                                         <p:attrNameLst>
                                           <p:attrName>style.visibility</p:attrName>
@@ -18406,7 +18381,7 @@
                                       <p:cBhvr additive="base">
                                         <p:cTn id="7" dur="500" fill="hold"/>
                                         <p:tgtEl>
-                                          <p:spTgt spid="6"/>
+                                          <p:spTgt spid="3"/>
                                         </p:tgtEl>
                                         <p:attrNameLst>
                                           <p:attrName>ppt_x</p:attrName>
@@ -18428,79 +18403,6 @@
                                     <p:anim calcmode="lin" valueType="num">
                                       <p:cBhvr additive="base">
                                         <p:cTn id="8" dur="500" fill="hold"/>
-                                        <p:tgtEl>
-                                          <p:spTgt spid="6"/>
-                                        </p:tgtEl>
-                                        <p:attrNameLst>
-                                          <p:attrName>ppt_y</p:attrName>
-                                        </p:attrNameLst>
-                                      </p:cBhvr>
-                                      <p:tavLst>
-                                        <p:tav tm="0">
-                                          <p:val>
-                                            <p:strVal val="1+#ppt_h/2"/>
-                                          </p:val>
-                                        </p:tav>
-                                        <p:tav tm="100000">
-                                          <p:val>
-                                            <p:strVal val="#ppt_y"/>
-                                          </p:val>
-                                        </p:tav>
-                                      </p:tavLst>
-                                    </p:anim>
-                                  </p:childTnLst>
-                                </p:cTn>
-                              </p:par>
-                              <p:par>
-                                <p:cTn id="9" presetID="2" presetClass="entr" presetSubtype="4" fill="hold" grpId="0" nodeType="withEffect">
-                                  <p:stCondLst>
-                                    <p:cond delay="0"/>
-                                  </p:stCondLst>
-                                  <p:childTnLst>
-                                    <p:set>
-                                      <p:cBhvr>
-                                        <p:cTn id="10" dur="1" fill="hold">
-                                          <p:stCondLst>
-                                            <p:cond delay="0"/>
-                                          </p:stCondLst>
-                                        </p:cTn>
-                                        <p:tgtEl>
-                                          <p:spTgt spid="3"/>
-                                        </p:tgtEl>
-                                        <p:attrNameLst>
-                                          <p:attrName>style.visibility</p:attrName>
-                                        </p:attrNameLst>
-                                      </p:cBhvr>
-                                      <p:to>
-                                        <p:strVal val="visible"/>
-                                      </p:to>
-                                    </p:set>
-                                    <p:anim calcmode="lin" valueType="num">
-                                      <p:cBhvr additive="base">
-                                        <p:cTn id="11" dur="500" fill="hold"/>
-                                        <p:tgtEl>
-                                          <p:spTgt spid="3"/>
-                                        </p:tgtEl>
-                                        <p:attrNameLst>
-                                          <p:attrName>ppt_x</p:attrName>
-                                        </p:attrNameLst>
-                                      </p:cBhvr>
-                                      <p:tavLst>
-                                        <p:tav tm="0">
-                                          <p:val>
-                                            <p:strVal val="#ppt_x"/>
-                                          </p:val>
-                                        </p:tav>
-                                        <p:tav tm="100000">
-                                          <p:val>
-                                            <p:strVal val="#ppt_x"/>
-                                          </p:val>
-                                        </p:tav>
-                                      </p:tavLst>
-                                    </p:anim>
-                                    <p:anim calcmode="lin" valueType="num">
-                                      <p:cBhvr additive="base">
-                                        <p:cTn id="12" dur="500" fill="hold"/>
                                         <p:tgtEl>
                                           <p:spTgt spid="3"/>
                                         </p:tgtEl>
@@ -18553,7 +18455,6 @@
     </p:tnLst>
     <p:bldLst>
       <p:bldP spid="3" grpId="0" animBg="1"/>
-      <p:bldP spid="6" grpId="0"/>
     </p:bldLst>
   </p:timing>
 </p:sld>
@@ -24997,16 +24898,16 @@
               <a:t>    repeat test </a:t>
             </a:r>
             <a:r>
-              <a:rPr lang="en-US" sz="2800">
+              <a:rPr lang="en-US" sz="2800" dirty="0" err="1">
                 <a:cs typeface="Courier New" pitchFamily="34" charset="-120"/>
               </a:rPr>
-              <a:t>oper  </a:t>
+              <a:t>oper</a:t>
             </a:r>
             <a:r>
               <a:rPr lang="en-US" sz="2800" dirty="0">
                 <a:cs typeface="Courier New" pitchFamily="34" charset="-120"/>
               </a:rPr>
-              <a:t>-- recurse</a:t>
+              <a:t>  -- recurse</a:t>
             </a:r>
           </a:p>
         </p:txBody>

</xml_diff>

<commit_message>
work on parser topic
</commit_message>
<xml_diff>
--- a/topic12-monads/unit-12a-lectures/talk-1/a-monads.pptx
+++ b/topic12-monads/unit-12a-lectures/talk-1/a-monads.pptx
@@ -9565,18 +9565,11 @@
           <a:p>
             <a:pPr algn="ctr" eaLnBrk="1" hangingPunct="1"/>
             <a:r>
-              <a:rPr kumimoji="1" lang="en-US" altLang="en-US" sz="2400">
-                <a:latin typeface="Tahoma" panose="020B0604030504040204" pitchFamily="34" charset="0"/>
-                <a:ea typeface="MS PGothic" panose="020B0600070205080204" pitchFamily="34" charset="-128"/>
-              </a:rPr>
-              <a:t>Topic 12 </a:t>
-            </a:r>
-            <a:r>
               <a:rPr kumimoji="1" lang="en-US" altLang="en-US" sz="2400" dirty="0">
                 <a:latin typeface="Tahoma" panose="020B0604030504040204" pitchFamily="34" charset="0"/>
                 <a:ea typeface="MS PGothic" panose="020B0600070205080204" pitchFamily="34" charset="-128"/>
               </a:rPr>
-              <a:t>– Monads</a:t>
+              <a:t>Topic 12 – Monads</a:t>
             </a:r>
           </a:p>
         </p:txBody>

</xml_diff>

<commit_message>
generate lab on QuickCheck
</commit_message>
<xml_diff>
--- a/topic12-monads/unit-12a-lectures/talk-1/a-monads.pptx
+++ b/topic12-monads/unit-12a-lectures/talk-1/a-monads.pptx
@@ -1347,7 +1347,7 @@
               <a:pPr>
                 <a:defRPr/>
               </a:pPr>
-              <a:t>4/13/26</a:t>
+              <a:t>4/20/26</a:t>
             </a:fld>
             <a:endParaRPr lang="en-US" dirty="0"/>
           </a:p>
@@ -1791,7 +1791,7 @@
               <a:pPr>
                 <a:defRPr/>
               </a:pPr>
-              <a:t>4/13/26</a:t>
+              <a:t>4/20/26</a:t>
             </a:fld>
             <a:endParaRPr lang="en-US" dirty="0"/>
           </a:p>
@@ -2157,7 +2157,7 @@
               <a:pPr>
                 <a:defRPr/>
               </a:pPr>
-              <a:t>4/13/26</a:t>
+              <a:t>4/20/26</a:t>
             </a:fld>
             <a:endParaRPr lang="en-US" dirty="0"/>
           </a:p>
@@ -2592,7 +2592,7 @@
               <a:pPr>
                 <a:defRPr/>
               </a:pPr>
-              <a:t>4/13/26</a:t>
+              <a:t>4/20/26</a:t>
             </a:fld>
             <a:endParaRPr lang="en-US" dirty="0"/>
           </a:p>
@@ -3190,7 +3190,7 @@
               <a:pPr>
                 <a:defRPr/>
               </a:pPr>
-              <a:t>4/13/26</a:t>
+              <a:t>4/20/26</a:t>
             </a:fld>
             <a:endParaRPr lang="en-US" dirty="0"/>
           </a:p>
@@ -3901,7 +3901,7 @@
               <a:pPr>
                 <a:defRPr/>
               </a:pPr>
-              <a:t>4/13/26</a:t>
+              <a:t>4/20/26</a:t>
             </a:fld>
             <a:endParaRPr lang="en-US" dirty="0"/>
           </a:p>
@@ -4844,7 +4844,7 @@
               <a:pPr>
                 <a:defRPr/>
               </a:pPr>
-              <a:t>4/13/26</a:t>
+              <a:t>4/20/26</a:t>
             </a:fld>
             <a:endParaRPr lang="en-US" dirty="0"/>
           </a:p>
@@ -5187,7 +5187,7 @@
               <a:pPr>
                 <a:defRPr/>
               </a:pPr>
-              <a:t>4/13/26</a:t>
+              <a:t>4/20/26</a:t>
             </a:fld>
             <a:endParaRPr lang="en-US" dirty="0"/>
           </a:p>
@@ -5480,7 +5480,7 @@
               <a:pPr>
                 <a:defRPr/>
               </a:pPr>
-              <a:t>4/13/26</a:t>
+              <a:t>4/20/26</a:t>
             </a:fld>
             <a:endParaRPr lang="en-US" dirty="0"/>
           </a:p>
@@ -5832,7 +5832,7 @@
               <a:pPr>
                 <a:defRPr/>
               </a:pPr>
-              <a:t>4/13/26</a:t>
+              <a:t>4/20/26</a:t>
             </a:fld>
             <a:endParaRPr lang="en-US" dirty="0"/>
           </a:p>
@@ -6250,7 +6250,7 @@
               <a:pPr>
                 <a:defRPr/>
               </a:pPr>
-              <a:t>4/13/26</a:t>
+              <a:t>4/20/26</a:t>
             </a:fld>
             <a:endParaRPr lang="en-US" dirty="0"/>
           </a:p>
@@ -6655,7 +6655,7 @@
               <a:pPr>
                 <a:defRPr/>
               </a:pPr>
-              <a:t>4/13/26</a:t>
+              <a:t>4/20/26</a:t>
             </a:fld>
             <a:endParaRPr lang="en-US" dirty="0"/>
           </a:p>
@@ -7190,7 +7190,7 @@
               <a:pPr>
                 <a:defRPr/>
               </a:pPr>
-              <a:t>4/13/26</a:t>
+              <a:t>4/20/26</a:t>
             </a:fld>
             <a:endParaRPr lang="en-US" dirty="0"/>
           </a:p>
@@ -7476,7 +7476,7 @@
               <a:pPr>
                 <a:defRPr/>
               </a:pPr>
-              <a:t>4/13/26</a:t>
+              <a:t>4/20/26</a:t>
             </a:fld>
             <a:endParaRPr lang="en-US" dirty="0"/>
           </a:p>
@@ -7661,7 +7661,7 @@
               <a:pPr>
                 <a:defRPr/>
               </a:pPr>
-              <a:t>4/13/26</a:t>
+              <a:t>4/20/26</a:t>
             </a:fld>
             <a:endParaRPr lang="en-US" dirty="0"/>
           </a:p>
@@ -8080,7 +8080,7 @@
               <a:pPr>
                 <a:defRPr/>
               </a:pPr>
-              <a:t>4/13/26</a:t>
+              <a:t>4/20/26</a:t>
             </a:fld>
             <a:endParaRPr lang="en-US" dirty="0"/>
           </a:p>
@@ -8518,7 +8518,7 @@
               <a:pPr>
                 <a:defRPr/>
               </a:pPr>
-              <a:t>4/13/26</a:t>
+              <a:t>4/20/26</a:t>
             </a:fld>
             <a:endParaRPr lang="en-US" dirty="0"/>
           </a:p>
@@ -8777,7 +8777,7 @@
               <a:pPr>
                 <a:defRPr/>
               </a:pPr>
-              <a:t>4/13/26</a:t>
+              <a:t>4/20/26</a:t>
             </a:fld>
             <a:endParaRPr lang="en-US" dirty="0"/>
           </a:p>
@@ -24844,7 +24844,11 @@
             </a:r>
             <a:r>
               <a:rPr lang="en-US" sz="2400" dirty="0"/>
-              <a:t> returns True.</a:t>
+              <a:t> </a:t>
+            </a:r>
+            <a:r>
+              <a:rPr lang="en-US" sz="2400"/>
+              <a:t>returns False.</a:t>
             </a:r>
             <a:endParaRPr lang="en-US" sz="2400" dirty="0">
               <a:latin typeface="Lucida Sans Typewriter" charset="0"/>

</xml_diff>